<commit_message>
Fix AF3 compute attribution: Garibaldi HPC, not AF3 server
Co-Authored-By: Claude Sonnet 4.6 <noreply@anthropic.com>
</commit_message>
<xml_diff>
--- a/ppt/Siglec6_Hackathon.pptx
+++ b/ppt/Siglec6_Hackathon.pptx
@@ -4094,7 +4094,7 @@
                   <a:srgbClr val="FFFFFF"/>
                 </a:solidFill>
               </a:rPr>
-              <a:t>AF3 server  ·  built-in MSA search</a:t>
+              <a:t>Garibaldi HPC  ·  built-in MSA search</a:t>
             </a:r>
           </a:p>
           <a:p>
@@ -4195,7 +4195,7 @@
                   <a:srgbClr val="FFFFFF"/>
                 </a:solidFill>
               </a:rPr>
-              <a:t>AF3 server  ·  pre-computed MSA</a:t>
+              <a:t>Garibaldi HPC  ·  pre-computed MSA</a:t>
             </a:r>
           </a:p>
           <a:p>
@@ -7419,7 +7419,7 @@
                   <a:srgbClr val="FFFFFF"/>
                 </a:solidFill>
               </a:rPr>
-              <a:t>• Version: AF3 web server (alphafoldserver.com), May 2025</a:t>
+              <a:t>• Compute: Garibaldi HPC (Scripps Research)</a:t>
             </a:r>
           </a:p>
         </p:txBody>
@@ -7518,7 +7518,7 @@
                   <a:srgbClr val="FFFFFF"/>
                 </a:solidFill>
               </a:rPr>
-              <a:t>• 42 jobs total (14 ligands × 3 methods)</a:t>
+              <a:t>• 28 jobs total (14 ligands × 2 AF3 conditions)</a:t>
             </a:r>
           </a:p>
         </p:txBody>

</xml_diff>